<commit_message>
docs: apply independent review fixes
Remove overclaims (dashboard pages, Telum, model/SHAP tense, s390x),
use the API's real reason order in the alert text, fix fail-safe scope,
latency owner, slide 10 wording, stats notes, responsible AI statuses,
fairness test labels and teammate handoffs. Rebuild the deck.

Co-Authored-By: Claude Opus 5.5 <noreply@anthropic.com>
</commit_message>
<xml_diff>
--- a/docs/deck/ZShield_deck_draft.pptx
+++ b/docs/deck/ZShield_deck_draft.pptx
@@ -1038,7 +1038,7 @@
           <a:lstStyle/>
           <a:p>
             <a:r>
-              <a:t>Use "designed for" and "deployable on". Do not say we used the on-chip accelerator unless Vishaal confirms it. If LinuxONE ran the API, say exactly that and show the screenshot.</a:t>
+              <a:t>Use "designed for" and "deployable on". Do not say we used or tested the on-chip accelerator or the compiler unless Vishaal confirms it. If LinuxONE ran the API, say exactly that and show the screenshot.</a:t>
             </a:r>
           </a:p>
           <a:p/>
@@ -1196,7 +1196,7 @@
           <a:p/>
           <a:p>
             <a:r>
-              <a:t>Visual needed: Four items: PR curve against the baseline, confusion matrix, SHAP summary, latency table labelled with the machine. (Supplier: Joshua (charts), Abhinava and Vishaal (latency table))</a:t>
+              <a:t>Visual needed: Four items: PR curve against the baseline, confusion matrix, SHAP summary, latency table labelled with the machine. (Supplier: Joshua (charts), Abhinava / Vishaal (latency table))</a:t>
             </a:r>
           </a:p>
         </p:txBody>
@@ -4925,7 +4925,7 @@
                 </a:solidFill>
                 <a:latin typeface="Arial"/>
               </a:rPr>
-              <a:t>•  After-the-fact freezing helps: more than ₹11,158 crore saved in more than 32.80 lakh complaints (till 30.06.2026). ZShield acts earlier.</a:t>
+              <a:t>•  Reporting after the fact still saves some money: more than ₹11,158 crore saved in more than 32.80 lakh complaints (till 30.06.2026). ZShield acts earlier.</a:t>
             </a:r>
           </a:p>
           <a:p>
@@ -5031,7 +5031,7 @@
                 </a:solidFill>
                 <a:latin typeface="Arial"/>
               </a:rPr>
-              <a:t>Source: PIB, MHA, "National Cyber Crime Data", 21 Jul 2026. "Saved" and "reported" cover different periods. We do not compute a recovery rate.</a:t>
+              <a:t>Source: PIB, MHA, "National Cyber Crime Data", 21 Jul 2026. "Saved" covers complaints till 30.06.2026; we do not compute a recovery rate.</a:t>
             </a:r>
           </a:p>
         </p:txBody>
@@ -6315,7 +6315,7 @@
                 </a:solidFill>
                 <a:latin typeface="Arial"/>
               </a:rPr>
-              <a:t>•  Scam Drain: at 2 AM the whole balance goes to a brand-new recipient. Result: HOLD.</a:t>
+              <a:t>•  Scam Drain: at 2 AM the whole balance goes to a brand-new recipient. Result: HOLD. The analyst clicks Block.</a:t>
             </a:r>
           </a:p>
           <a:p>
@@ -6347,7 +6347,7 @@
                 </a:solidFill>
                 <a:latin typeface="Arial"/>
               </a:rPr>
-              <a:t>•  Normal Day: hundreds of honest payments pass in milliseconds. Then the analyst clicks Block.</a:t>
+              <a:t>•  Normal Day: hundreds of honest payments pass in milliseconds.</a:t>
             </a:r>
           </a:p>
         </p:txBody>
@@ -6437,7 +6437,7 @@
                 </a:solidFill>
                 <a:latin typeface="Arial"/>
               </a:rPr>
-              <a:t>Scam Drain alert text, as produced by the code: "We paused a payment of ₹9,000 for a safety review. Reason: account emptied in one transfer, large payment at an unusual hour, new recipient. Our team will contact you. Never share your OTP or PIN."</a:t>
+              <a:t>Example alert text (example; the live amount comes from the demo story): "We paused a payment of ₹9,000 for a safety review. Reason: account emptied in one transfer, new recipient, large payment at an unusual hour. Our team will contact you. Never share your OTP or PIN."</a:t>
             </a:r>
           </a:p>
         </p:txBody>
@@ -6677,7 +6677,7 @@
                 </a:solidFill>
                 <a:latin typeface="Arial"/>
               </a:rPr>
-              <a:t>•  Stream, then POST /score, live features, ONNX model, decision engine.</a:t>
+              <a:t>•  Stream, then POST /score, live features, ONNX model (placeholder rule until Joshua's model lands), decision engine.</a:t>
             </a:r>
           </a:p>
           <a:p>
@@ -6709,7 +6709,7 @@
                 </a:solidFill>
                 <a:latin typeface="Arial"/>
               </a:rPr>
-              <a:t>•  If any step fails, the result is STEP_UP and the error is stored.</a:t>
+              <a:t>•  If scoring fails, the result is STEP_UP and the error is stored.</a:t>
             </a:r>
           </a:p>
         </p:txBody>
@@ -6895,7 +6895,7 @@
                 </a:solidFill>
                 <a:latin typeface="Arial"/>
               </a:rPr>
-              <a:t>ZShield is designed for IBM Z and deployable on LinuxONE, next to where payments already run.</a:t>
+              <a:t>ZShield is designed for IBM Z and deployable on LinuxONE, next to where many banks already run core payments.</a:t>
             </a:r>
           </a:p>
         </p:txBody>
@@ -7033,13 +7033,13 @@
               </a:spcAft>
             </a:pPr>
             <a:r>
-              <a:rPr sz="2000">
+              <a:rPr sz="1800">
                 <a:solidFill>
                   <a:srgbClr val="161616"/>
                 </a:solidFill>
                 <a:latin typeface="Arial"/>
               </a:rPr>
-              <a:t>•  Core payments already run on IBM Z. Scoring next to the transaction avoids moving sensitive data across networks.</a:t>
+              <a:t>•  Many banks run core payment systems on IBM Z. Scoring next to the transaction avoids moving sensitive data across networks.</a:t>
             </a:r>
           </a:p>
           <a:p>
@@ -7049,13 +7049,13 @@
               </a:spcAft>
             </a:pPr>
             <a:r>
-              <a:rPr sz="2000">
+              <a:rPr sz="1800">
                 <a:solidFill>
                   <a:srgbClr val="161616"/>
                 </a:solidFill>
                 <a:latin typeface="Arial"/>
               </a:rPr>
-              <a:t>•  Low, predictable latency matters before settlement. Telum-class processors include on-chip AI acceleration for in-transaction inference. ZShield is designed to use it.</a:t>
+              <a:t>•  IBM Telum processors include an on-chip AI accelerator for in-transaction inference. Because our model is ONNX, it could be compiled for it (for example with the IBM Z Deep Learning Compiler). Not tested.</a:t>
             </a:r>
           </a:p>
           <a:p>
@@ -7065,13 +7065,13 @@
               </a:spcAft>
             </a:pPr>
             <a:r>
-              <a:rPr sz="2000">
+              <a:rPr sz="1800">
                 <a:solidFill>
                   <a:srgbClr val="161616"/>
                 </a:solidFill>
                 <a:latin typeface="Arial"/>
               </a:rPr>
-              <a:t>•  ONNX keeps the model portable to s390x. IBM Z security and reliability match our responsible-AI design.</a:t>
+              <a:t>•  ONNX is a portable format; on s390x it needs ONNX Runtime built for s390x or the IBM Z Deep Learning Compiler (Vishaal to confirm).</a:t>
             </a:r>
           </a:p>
         </p:txBody>
@@ -7161,7 +7161,7 @@
                 </a:solidFill>
                 <a:latin typeface="Arial"/>
               </a:rPr>
-              <a:t>Scale: UPI recorded 2,366 crore transactions in July 2026 (PIB, key statistics attributed to NPCI). This is context, not a benchmark of ours.</a:t>
+              <a:t>Low, predictable latency matters before settlement, and IBM Z security and reliability match our responsible-AI design. Scale: UPI recorded 2,366 crore transactions in July 2026 (PIB, key statistics attributed to NPCI). This is context, not a benchmark of ours.</a:t>
             </a:r>
           </a:p>
         </p:txBody>
@@ -7523,7 +7523,7 @@
                 </a:solidFill>
                 <a:latin typeface="Arial"/>
               </a:rPr>
-              <a:t>PaySim is synthetic and relatively easy, so real-world performance is unknown.</a:t>
+              <a:t>Method as planned; results on slide 8. PaySim is synthetic and relatively easy, so real-world performance is unknown.</a:t>
             </a:r>
           </a:p>
         </p:txBody>
@@ -7850,7 +7850,7 @@
                 </a:solidFill>
                 <a:latin typeface="Arial"/>
               </a:rPr>
-              <a:t>PLACEHOLDER: PR curve, model vs baseline; confusion matrix; SHAP summary; latency table (Joshua, by 4 PM)</a:t>
+              <a:t>PLACEHOLDER: PR curve, model vs baseline; confusion matrix; SHAP summary; latency table (charts: Joshua; latency table: Abhinava / Vishaal; by 4 PM)</a:t>
             </a:r>
           </a:p>
         </p:txBody>

</xml_diff>

<commit_message>
docs: state only built and measured work; move pending items to TODO
Deck, demo script, abstract, problem statement, personas, responsible AI
page and README no longer mention the trained model, SHAP, LinuxONE runs,
Telum, live Granite, dashboard pages or fairness numbers. Each is in
docs/TODO.md with owner, done-when, location and text to paste. Demo and
results now use a real sample replay and a laptop load test
(docs/deck/measured_17oct.md). Deck rebuilt.

Co-Authored-By: Claude Opus 5.5 <noreply@anthropic.com>
</commit_message>
<xml_diff>
--- a/docs/deck/ZShield_deck_draft.pptx
+++ b/docs/deck/ZShield_deck_draft.pptx
@@ -588,13 +588,13 @@
           <a:lstStyle/>
           <a:p>
             <a:r>
-              <a:t>Quote the demo number only from the real run. Do not say this recovers money at any rate. Close on the problem line: score, stop, explain, keep a human in control.</a:t>
+              <a:t>Quote only the replay numbers and the sourced figure. Close on the problem line: score, stop, explain, keep a human in control.</a:t>
             </a:r>
           </a:p>
           <a:p/>
           <a:p>
             <a:r>
-              <a:t>Visual needed: Dashboard Impact page screenshot. (Supplier: Armaan)</a:t>
+              <a:t>Visual needed: Crop of the dashboard tiles after the sample replay. (Supplier: Arun)</a:t>
             </a:r>
           </a:p>
         </p:txBody>
@@ -810,7 +810,7 @@
           <a:lstStyle/>
           <a:p>
             <a:r>
-              <a:t>Explain the three lanes in one breath. Stress that STEP_UP is the middle path that protects honest customers. The GenAI never makes or changes a decision.</a:t>
+              <a:t>Explain the three lanes in one breath. Stress that STEP_UP is the middle path that protects honest customers. The alert text never makes or changes a decision.</a:t>
             </a:r>
           </a:p>
           <a:p/>
@@ -886,13 +886,13 @@
           <a:lstStyle/>
           <a:p>
             <a:r>
-              <a:t>Run the demo live. If it fails, play the backup clip and show the audit log. Replay each story after a reset so decisions are fresh. Full wording is in demo_script.md.</a:t>
+              <a:t>Run the replay live with the producer. Block the held payment from the API docs page, then show BLOCK in the dashboard table. If anything fails, show the audit log in /alerts. Full wording is in demo_script.md.</a:t>
             </a:r>
           </a:p>
           <a:p/>
           <a:p>
             <a:r>
-              <a:t>Visual needed: Two screenshots: Live Feed during Normal Day, and Alert Detail for the held Scam Drain payment with the Block button. (Supplier: Armaan (docs/screenshots/))</a:t>
+              <a:t>Visual needed: Screenshot of the current dashboard (Processed, Flagged, Value intercepted, Avg latency, and the flagged table with alert text and analyst status BLOCK). (Supplier: Arun)</a:t>
             </a:r>
           </a:p>
         </p:txBody>
@@ -962,13 +962,13 @@
           <a:lstStyle/>
           <a:p>
             <a:r>
-              <a:t>Walk the path left to right. Point out that the GenAI sits after the decision and cannot change it. Mention the fail-safe once.</a:t>
+              <a:t>Walk the path left to right. Point out that the alert step sits after the decision and cannot change it. Mention the fail-safe once.</a:t>
             </a:r>
           </a:p>
           <a:p/>
           <a:p>
             <a:r>
-              <a:t>Visual needed: Block diagram: stream, FastAPI /score, live features, ONNX model, decision engine, audit log (SQLite), dashboard (Streamlit). GenAI alert branch off the decision engine. (Supplier: Vishaal (diagram), Arun (labels))</a:t>
+              <a:t>Visual needed: Block diagram: producer.py, FastAPI /score, live features (state store), scorer, decision engine, alert text (flagged only), audit log (SQLite), dashboard (Streamlit), analyst action (POST /analyst_action). (Supplier: Arun)</a:t>
             </a:r>
           </a:p>
         </p:txBody>
@@ -1038,13 +1038,13 @@
           <a:lstStyle/>
           <a:p>
             <a:r>
-              <a:t>Use "designed for" and "deployable on". Do not say we used or tested the on-chip accelerator or the compiler unless Vishaal confirms it. If LinuxONE ran the API, say exactly that and show the screenshot.</a:t>
+              <a:t>Say "designed for". Do not say it runs on IBM Z or uses any IBM Z accelerator. The laptop number is a laptop number.</a:t>
             </a:r>
           </a:p>
           <a:p/>
           <a:p>
             <a:r>
-              <a:t>Visual needed: Screenshot of /health and a /score call on LinuxONE, plus one line stating exactly what ran. If nothing ran, keep the "designed for / deployable on" wording and say so. (Supplier: Vishaal)</a:t>
+              <a:t>Visual needed: Simple diagram: payment switch, ZShield scoring step, settlement. Label it "design". (Supplier: Arun)</a:t>
             </a:r>
           </a:p>
         </p:txBody>
@@ -1114,13 +1114,13 @@
           <a:lstStyle/>
           <a:p>
             <a:r>
-              <a:t>Say why accuracy is misleading when fraud is rare. Say the baseline exists so the boosted-tree model has to earn its place. Name the limit: synthetic data.</a:t>
+              <a:t>Stress "past events only": the current payment is added to history after its features are computed, so nothing leaks from the future.</a:t>
             </a:r>
           </a:p>
           <a:p/>
           <a:p>
             <a:r>
-              <a:t>Visual needed: One EDA chart that shows how rare fraud is and which transaction types carry it. (Supplier: Balaa)</a:t>
+              <a:t>Visual needed: A two-column table of the features listed on this slide, from features/features.py and api/state.py. (Supplier: Arun)</a:t>
             </a:r>
           </a:p>
         </p:txBody>
@@ -1190,13 +1190,13 @@
           <a:lstStyle/>
           <a:p>
             <a:r>
-              <a:t>Fill every number from a real run and label the machine. If the real model is not in by the deadline, say so on this slide. Never show the placeholder scorer's numbers as model results.</a:t>
+              <a:t>Name the machine and the scorer every time you quote a number. These are pipeline numbers, not fraud-detection accuracy.</a:t>
             </a:r>
           </a:p>
           <a:p/>
           <a:p>
             <a:r>
-              <a:t>Visual needed: Four items: PR curve against the baseline, confusion matrix, SHAP summary, latency table labelled with the machine. (Supplier: Joshua (charts), Abhinava / Vishaal (latency table))</a:t>
+              <a:t>Visual needed: Table: p50, p95, p99 end to end and inside the API, for 1 and 8 clients, with the machine named. (Supplier: Arun)</a:t>
             </a:r>
           </a:p>
         </p:txBody>
@@ -1266,13 +1266,13 @@
           <a:lstStyle/>
           <a:p>
             <a:r>
-              <a:t>Say what is built and what is pending. Name the limits: synthetic data, drift, fraudsters adapt, fairness checked only through proxies. Honesty here is a strength.</a:t>
+              <a:t>Say what each point is and where a judge can see it in the repo. Name the limits plainly. Honesty here is a strength.</a:t>
             </a:r>
           </a:p>
           <a:p/>
           <a:p>
             <a:r>
-              <a:t>Visual needed: Six icons for the six short-version bullets, plus the fairness table when Joshua's numbers arrive. (Supplier: Arun (graphic), Joshua (numbers))</a:t>
+              <a:t>Visual needed: Six icons for the six short-version bullets in docs/responsible_ai.md. (Supplier: Arun)</a:t>
             </a:r>
           </a:p>
         </p:txBody>
@@ -4582,7 +4582,7 @@
                 </a:solidFill>
                 <a:latin typeface="Arial"/>
               </a:rPr>
-              <a:t>PLACEHOLDER: stat card, NCRP frauds reported 2021 to 2025, from the RBI table only (Arun, by 4 PM)</a:t>
+              <a:t>VISUAL: stat card, NCRP frauds reported 2021 to 2025, from the RBI table (Arun)</a:t>
             </a:r>
           </a:p>
         </p:txBody>
@@ -4909,7 +4909,7 @@
                 </a:solidFill>
                 <a:latin typeface="Arial"/>
               </a:rPr>
-              <a:t>•  In our demo run, value intercepted: [[NEEDS: value intercepted from demo run]]. It excludes payments an analyst approved.</a:t>
+              <a:t>•  In the sample replay, ₹79,500 in two drain payments was held before settlement.</a:t>
             </a:r>
           </a:p>
           <a:p>
@@ -4925,7 +4925,7 @@
                 </a:solidFill>
                 <a:latin typeface="Arial"/>
               </a:rPr>
-              <a:t>•  Reporting after the fact still saves some money: more than ₹11,158 crore saved in more than 32.80 lakh complaints (till 30.06.2026). ZShield acts earlier.</a:t>
+              <a:t>•  Honest customers: 245 of 252 payments went through with no extra step.</a:t>
             </a:r>
           </a:p>
           <a:p>
@@ -4941,7 +4941,7 @@
                 </a:solidFill>
                 <a:latin typeface="Arial"/>
               </a:rPr>
-              <a:t>•  Next: real model on LinuxONE, SHAP reasons, pilot with real review queues, drift monitoring.</a:t>
+              <a:t>•  Reporting after the fact still saves some money: more than ₹11,158 crore saved in more than 32.80 lakh complaints (till 30.06.2026). ZShield acts earlier.</a:t>
             </a:r>
           </a:p>
         </p:txBody>
@@ -4996,7 +4996,7 @@
                 </a:solidFill>
                 <a:latin typeface="Arial"/>
               </a:rPr>
-              <a:t>PLACEHOLDER: impact panel, demo-run counts and value intercepted from /stats (Armaan, by 4 PM)</a:t>
+              <a:t>VISUAL: impact panel, the dashboard's Value intercepted and Processed tiles after the replay (Arun)</a:t>
             </a:r>
           </a:p>
         </p:txBody>
@@ -5031,7 +5031,7 @@
                 </a:solidFill>
                 <a:latin typeface="Arial"/>
               </a:rPr>
-              <a:t>Source: PIB, MHA, "National Cyber Crime Data", 21 Jul 2026. "Saved" covers complaints till 30.06.2026; we do not compute a recovery rate.</a:t>
+              <a:t>Replay amounts are synthetic. Source for the national figure: PIB, MHA, "National Cyber Crime Data", 21 Jul 2026. "Saved" covers complaints till 30.06.2026; we do not compute a recovery rate.</a:t>
             </a:r>
           </a:p>
         </p:txBody>
@@ -5335,7 +5335,7 @@
                 </a:solidFill>
                 <a:latin typeface="Arial"/>
               </a:rPr>
-              <a:t>•  Not used on slides: Stat 1 (RBI Annual Report 2024-25) and Stat 3 (MHA, Lok Sabha, 2 Dec 2025). Their 2024 numbers differ from other cuts and must not be mixed with the opener.</a:t>
+              <a:t>•  Our measurements (slides 4, 6, 8, 10): docs/deck/measured_17oct.md, 17 Oct 2026, laptop (Intel i7, x86), rule-based scorer, synthetic sample stream.</a:t>
             </a:r>
           </a:p>
           <a:p>
@@ -5678,7 +5678,7 @@
                 </a:solidFill>
                 <a:latin typeface="Arial"/>
               </a:rPr>
-              <a:t>PLACEHOLDER: three persona cards, Meera / Kamla / The Caller, marked "illustrative" (Arun, by 4 PM)</a:t>
+              <a:t>VISUAL: three persona cards, Meera / Kamla / The Caller, marked "illustrative" (Arun)</a:t>
             </a:r>
           </a:p>
         </p:txBody>
@@ -5969,7 +5969,7 @@
                 </a:solidFill>
                 <a:latin typeface="Arial"/>
               </a:rPr>
-              <a:t>•  Flagged payments get the top 3 reasons and a plain-language alert.</a:t>
+              <a:t>•  Flagged payments get up to 3 plain reasons and a short customer alert.</a:t>
             </a:r>
           </a:p>
           <a:p>
@@ -6040,7 +6040,7 @@
                 </a:solidFill>
                 <a:latin typeface="Arial"/>
               </a:rPr>
-              <a:t>PLACEHOLDER: three-lane routing graphic, APPROVE / STEP_UP / HOLD (Arun, by 4 PM)</a:t>
+              <a:t>VISUAL: three-lane routing graphic, APPROVE / STEP_UP / HOLD (Arun)</a:t>
             </a:r>
           </a:p>
         </p:txBody>
@@ -6075,7 +6075,7 @@
                 </a:solidFill>
                 <a:latin typeface="Arial"/>
               </a:rPr>
-              <a:t>Alert text is made from fixed templates by default. A language model is optional, and every output is checked.</a:t>
+              <a:t>The score and the reasons come from a rule-based scorer. Alerts come from fixed templates, and every alert is checked before it is used.</a:t>
             </a:r>
           </a:p>
         </p:txBody>
@@ -6171,7 +6171,7 @@
                 </a:solidFill>
                 <a:latin typeface="Arial"/>
               </a:rPr>
-              <a:t>Three stories show the system working: a drain is held, a burst is flagged, a normal day flows.</a:t>
+              <a:t>Three stories in one replay: a drain is held, a burst is flagged, a normal day flows.</a:t>
             </a:r>
           </a:p>
         </p:txBody>
@@ -6315,7 +6315,7 @@
                 </a:solidFill>
                 <a:latin typeface="Arial"/>
               </a:rPr>
-              <a:t>•  Scam Drain: at 2 AM the whole balance goes to a brand-new recipient. Result: HOLD. The analyst clicks Block.</a:t>
+              <a:t>•  Scam Drain: at 2 AM, ₹48,000, the whole balance, goes to a brand-new recipient. Result: HOLD. The analyst blocks it.</a:t>
             </a:r>
           </a:p>
           <a:p>
@@ -6331,7 +6331,7 @@
                 </a:solidFill>
                 <a:latin typeface="Arial"/>
               </a:rPr>
-              <a:t>•  Mule Burst: one destination receives many transfers fast. Result: flagged.</a:t>
+              <a:t>•  Mule Burst: ten payers send money to one account. From the sixth transfer on, each one is STEP_UP.</a:t>
             </a:r>
           </a:p>
           <a:p>
@@ -6347,7 +6347,7 @@
                 </a:solidFill>
                 <a:latin typeface="Arial"/>
               </a:rPr>
-              <a:t>•  Normal Day: hundreds of honest payments pass in milliseconds.</a:t>
+              <a:t>•  Normal Day: 245 of 252 payments are approved with no extra step.</a:t>
             </a:r>
           </a:p>
         </p:txBody>
@@ -6402,7 +6402,7 @@
                 </a:solidFill>
                 <a:latin typeface="Arial"/>
               </a:rPr>
-              <a:t>PLACEHOLDER: dashboard screenshots, Live Feed and Alert Detail with the Scam Drain HOLD (Armaan, by 4 PM)</a:t>
+              <a:t>VISUAL: screenshot of the dashboard after the replay, with the two HOLD rows (Arun)</a:t>
             </a:r>
           </a:p>
         </p:txBody>
@@ -6437,7 +6437,7 @@
                 </a:solidFill>
                 <a:latin typeface="Arial"/>
               </a:rPr>
-              <a:t>Example alert text (example; the live amount comes from the demo story): "We paused a payment of ₹9,000 for a safety review. Reason: account emptied in one transfer, new recipient, large payment at an unusual hour. Our team will contact you. Never share your OTP or PIN."</a:t>
+              <a:t>Alert text for the held payment, as produced: "We paused a payment of ₹48,000 for a safety review. Reason: account emptied in one transfer, new recipient, large payment at an unusual hour. Our team will contact you. Never share your OTP or PIN." Data: the synthetic sample stream in the repo (docs/samples/sample_stream.csv).</a:t>
             </a:r>
           </a:p>
         </p:txBody>
@@ -6677,7 +6677,7 @@
                 </a:solidFill>
                 <a:latin typeface="Arial"/>
               </a:rPr>
-              <a:t>•  Stream, then POST /score, live features, ONNX model (placeholder rule until Joshua's model lands), decision engine.</a:t>
+              <a:t>•  Stream (producer.py), then POST /score, live features, scorer, decision engine.</a:t>
             </a:r>
           </a:p>
           <a:p>
@@ -6693,7 +6693,7 @@
                 </a:solidFill>
                 <a:latin typeface="Arial"/>
               </a:rPr>
-              <a:t>•  Flagged payments get reasons and an alert. Every decision goes to an audit log, then the dashboard.</a:t>
+              <a:t>•  Flagged payments get reasons and an alert. Every decision goes to a SQLite audit log, then the dashboard.</a:t>
             </a:r>
           </a:p>
           <a:p>
@@ -6764,7 +6764,7 @@
                 </a:solidFill>
                 <a:latin typeface="Arial"/>
               </a:rPr>
-              <a:t>PLACEHOLDER: architecture diagram, stream to dashboard, with the GenAI step and fail-safe marked (Vishaal, by 4 PM)</a:t>
+              <a:t>VISUAL: architecture diagram as built, stream to dashboard, with the alert step and fail-safe marked (Arun)</a:t>
             </a:r>
           </a:p>
         </p:txBody>
@@ -6799,7 +6799,7 @@
                 </a:solidFill>
                 <a:latin typeface="Arial"/>
               </a:rPr>
-              <a:t>The backend latency measured so far is from a placeholder rule scorer, not the real model.</a:t>
+              <a:t>Live features use the payment itself and past events only. The API also loads an ONNX model file when one is provided (tested with a stand-in model).</a:t>
             </a:r>
           </a:p>
         </p:txBody>
@@ -6895,7 +6895,7 @@
                 </a:solidFill>
                 <a:latin typeface="Arial"/>
               </a:rPr>
-              <a:t>ZShield is designed for IBM Z and deployable on LinuxONE, next to where many banks already run core payments.</a:t>
+              <a:t>ZShield is designed for IBM Z / LinuxONE: decide inside the payment flow, before settlement.</a:t>
             </a:r>
           </a:p>
         </p:txBody>
@@ -7033,13 +7033,13 @@
               </a:spcAft>
             </a:pPr>
             <a:r>
-              <a:rPr sz="1800">
+              <a:rPr sz="2000">
                 <a:solidFill>
                   <a:srgbClr val="161616"/>
                 </a:solidFill>
                 <a:latin typeface="Arial"/>
               </a:rPr>
-              <a:t>•  Many banks run core payment systems on IBM Z. Scoring next to the transaction avoids moving sensitive data across networks.</a:t>
+              <a:t>•  Designed to score next to the transaction, so sensitive payment data does not travel to an outside ML server.</a:t>
             </a:r>
           </a:p>
           <a:p>
@@ -7049,13 +7049,13 @@
               </a:spcAft>
             </a:pPr>
             <a:r>
-              <a:rPr sz="1800">
+              <a:rPr sz="2000">
                 <a:solidFill>
                   <a:srgbClr val="161616"/>
                 </a:solidFill>
                 <a:latin typeface="Arial"/>
               </a:rPr>
-              <a:t>•  IBM Telum processors include an on-chip AI accelerator for in-transaction inference. Because our model is ONNX, it could be compiled for it (for example with the IBM Z Deep Learning Compiler). Not tested.</a:t>
+              <a:t>•  The decision step is small and fast: about 0.04 ms per payment in our laptop test.</a:t>
             </a:r>
           </a:p>
           <a:p>
@@ -7065,13 +7065,13 @@
               </a:spcAft>
             </a:pPr>
             <a:r>
-              <a:rPr sz="1800">
+              <a:rPr sz="2000">
                 <a:solidFill>
                   <a:srgbClr val="161616"/>
                 </a:solidFill>
                 <a:latin typeface="Arial"/>
               </a:rPr>
-              <a:t>•  ONNX is a portable format; on s390x it needs ONNX Runtime built for s390x or the IBM Z Deep Learning Compiler (Vishaal to confirm).</a:t>
+              <a:t>•  The scoring service needs only a short list of Python packages (requirements-api.txt).</a:t>
             </a:r>
           </a:p>
         </p:txBody>
@@ -7126,7 +7126,7 @@
                 </a:solidFill>
                 <a:latin typeface="Arial"/>
               </a:rPr>
-              <a:t>PLACEHOLDER: [[NEEDS: Vishaal: what actually ran on LinuxONE, with screenshot]]</a:t>
+              <a:t>VISUAL: diagram of ZShield inside the payment flow on IBM Z / LinuxONE, labelled "design" (Arun)</a:t>
             </a:r>
           </a:p>
         </p:txBody>
@@ -7161,7 +7161,7 @@
                 </a:solidFill>
                 <a:latin typeface="Arial"/>
               </a:rPr>
-              <a:t>Low, predictable latency matters before settlement, and IBM Z security and reliability match our responsible-AI design. Scale: UPI recorded 2,366 crore transactions in July 2026 (PIB, key statistics attributed to NPCI). This is context, not a benchmark of ours.</a:t>
+              <a:t>Scale: UPI recorded 2,366 crore transactions in July 2026 (PIB, key statistics attributed to NPCI). This is context, not a benchmark of ours. Laptop test: Intel i7, x86, rule-based scorer.</a:t>
             </a:r>
           </a:p>
         </p:txBody>
@@ -7257,7 +7257,7 @@
                 </a:solidFill>
                 <a:latin typeface="Arial"/>
               </a:rPr>
-              <a:t>We test the way a bank would: time-based split, no leakage, and honest metrics.</a:t>
+              <a:t>Synthetic payments, and features built only from what is known at the moment of payment.</a:t>
             </a:r>
           </a:p>
         </p:txBody>
@@ -7401,7 +7401,7 @@
                 </a:solidFill>
                 <a:latin typeface="Arial"/>
               </a:rPr>
-              <a:t>•  PaySim synthetic payments (Kaggle). No real personal data. Split by time (step), no leakage.</a:t>
+              <a:t>•  PaySim-format synthetic data. No real customers, names or demographics.</a:t>
             </a:r>
           </a:p>
           <a:p>
@@ -7417,7 +7417,7 @@
                 </a:solidFill>
                 <a:latin typeface="Arial"/>
               </a:rPr>
-              <a:t>•  Class weights for rare fraud. Metrics: PR-AUC and recall at a fixed false-positive rate. No accuracy.</a:t>
+              <a:t>•  Features: balance mismatches, amount-to-balance ratio, full-drain flag, hour of day, payment type, new recipient.</a:t>
             </a:r>
           </a:p>
           <a:p>
@@ -7433,7 +7433,7 @@
                 </a:solidFill>
                 <a:latin typeface="Arial"/>
               </a:rPr>
-              <a:t>•  Logistic regression baseline. Thresholds set by cost: a missed fraud costs more than an extra check.</a:t>
+              <a:t>•  History features from past events only: sender's recent payments and recipient's recent inbound payments.</a:t>
             </a:r>
           </a:p>
         </p:txBody>
@@ -7488,7 +7488,7 @@
                 </a:solidFill>
                 <a:latin typeface="Arial"/>
               </a:rPr>
-              <a:t>PLACEHOLDER: EDA chart, fraud by type and over time (Balaa, docs/eda/, by 4 PM)</a:t>
+              <a:t>VISUAL: feature table, name and plain meaning (Arun)</a:t>
             </a:r>
           </a:p>
         </p:txBody>
@@ -7523,7 +7523,7 @@
                 </a:solidFill>
                 <a:latin typeface="Arial"/>
               </a:rPr>
-              <a:t>Method as planned; results on slide 8. PaySim is synthetic and relatively easy, so real-world performance is unknown.</a:t>
+              <a:t>PaySim is synthetic and relatively easy, so real-world performance is unknown. Code: features/features.py and api/state.py.</a:t>
             </a:r>
           </a:p>
         </p:txBody>
@@ -7619,7 +7619,7 @@
                 </a:solidFill>
                 <a:latin typeface="Arial"/>
               </a:rPr>
-              <a:t>We report ranking quality, catch rate at a fixed false-alarm rate, and latency, all measured, none assumed.</a:t>
+              <a:t>Measured so far: decisions in milliseconds, and both drain payments held.</a:t>
             </a:r>
           </a:p>
         </p:txBody>
@@ -7763,7 +7763,7 @@
                 </a:solidFill>
                 <a:latin typeface="Arial"/>
               </a:rPr>
-              <a:t>•  PR-AUC: [[NEEDS: PR-AUC from Joshua]] against baseline [[NEEDS: baseline PR-AUC from Joshua]].</a:t>
+              <a:t>•  Load test, 5,000 payments, 0 errors: p95 3.2 ms end to end; 375 payments per second one at a time, 718 with 8 clients.</a:t>
             </a:r>
           </a:p>
           <a:p>
@@ -7779,7 +7779,7 @@
                 </a:solidFill>
                 <a:latin typeface="Arial"/>
               </a:rPr>
-              <a:t>•  Recall at fixed FPR: [[NEEDS: recall at fixed FPR from Joshua]]. Confusion matrix and SHAP summary: [[NEEDS: charts from Joshua]].</a:t>
+              <a:t>•  Sample replay, 252 payments: 245 approved, 5 STEP_UP, 2 HOLD. Both full-drain payments were held.</a:t>
             </a:r>
           </a:p>
           <a:p>
@@ -7795,7 +7795,7 @@
                 </a:solidFill>
                 <a:latin typeface="Arial"/>
               </a:rPr>
-              <a:t>•  Latency: p95 [[NEEDS: p95 latency on LinuxONE from Vishaal/Abhinava]].</a:t>
+              <a:t>•  Alert safety: 119 offline tests pass; 25,664 template cases checked with no false rejection.</a:t>
             </a:r>
           </a:p>
         </p:txBody>
@@ -7850,7 +7850,7 @@
                 </a:solidFill>
                 <a:latin typeface="Arial"/>
               </a:rPr>
-              <a:t>PLACEHOLDER: PR curve, model vs baseline; confusion matrix; SHAP summary; latency table (charts: Joshua; latency table: Abhinava / Vishaal; by 4 PM)</a:t>
+              <a:t>VISUAL: latency and throughput table from docs/deck/measured_17oct.md (Arun)</a:t>
             </a:r>
           </a:p>
         </p:txBody>
@@ -7885,7 +7885,7 @@
                 </a:solidFill>
                 <a:latin typeface="Arial"/>
               </a:rPr>
-              <a:t>Honest note: the backend latency measured so far comes from a placeholder rule scorer on x86, not the real model and not IBM Z. We do not quote it as a result.</a:t>
+              <a:t>Measured 17 Oct 2026 on a laptop (Intel i7, x86) with the rule-based scorer, not on IBM Z. Tables: docs/deck/measured_17oct.md.</a:t>
             </a:r>
           </a:p>
         </p:txBody>
@@ -8141,7 +8141,7 @@
                 </a:solidFill>
                 <a:latin typeface="Arial"/>
               </a:rPr>
-              <a:t>•  GenAI only rephrases facts we give it. Output is checked, with a template fallback. It cannot change a decision.</a:t>
+              <a:t>•  Alert text only rephrases facts we give it. Every word is checked, with a template fallback. It cannot change a decision.</a:t>
             </a:r>
           </a:p>
           <a:p>
@@ -8157,7 +8157,7 @@
                 </a:solidFill>
                 <a:latin typeface="Arial"/>
               </a:rPr>
-              <a:t>•  Fail-safe to STEP_UP. Every decision is logged. Fairness is checked by type and amount band: [[NEEDS: fairness numbers from Joshua]].</a:t>
+              <a:t>•  Fail-safe to STEP_UP. Every decision and analyst action is logged.</a:t>
             </a:r>
           </a:p>
         </p:txBody>
@@ -8212,7 +8212,7 @@
                 </a:solidFill>
                 <a:latin typeface="Arial"/>
               </a:rPr>
-              <a:t>PLACEHOLDER: responsible-AI checklist graphic and fairness table (Arun graphic; Joshua numbers, by 4 PM)</a:t>
+              <a:t>VISUAL: six-point responsible-AI checklist graphic (Arun)</a:t>
             </a:r>
           </a:p>
         </p:txBody>
@@ -8247,7 +8247,7 @@
                 </a:solidFill>
                 <a:latin typeface="Arial"/>
               </a:rPr>
-              <a:t>Status: validator, fail-safe and audit log are built. SHAP reasons and the fairness table are pending. See docs/responsible_ai.md.</a:t>
+              <a:t>See docs/responsible_ai.md. Limits: synthetic data, drift over time, fraudsters adapt.</a:t>
             </a:r>
           </a:p>
         </p:txBody>

</xml_diff>